<commit_message>
feat: add tier-list styling with standard S-F color coding
Add tierlist_slide() to _shared/theme.py, colored red-to-green by tier
letter like common tier-list makers, and use it for the two tier tables
in bloque0_ecosistema.
</commit_message>
<xml_diff>
--- a/bloque0_ecosistema/csbc26_b0_ecosistema.pptx
+++ b/bloque0_ecosistema/csbc26_b0_ecosistema.pptx
@@ -6062,9 +6062,9 @@
                 <a:tableStyleId>{5C22544A-7EE6-4342-B048-85BDC9FD1C3A}</a:tableStyleId>
               </a:tblPr>
               <a:tblGrid>
-                <a:gridCol w="3352800"/>
-                <a:gridCol w="3352800"/>
-                <a:gridCol w="3352800"/>
+                <a:gridCol w="822960"/>
+                <a:gridCol w="4617720"/>
+                <a:gridCol w="4617720"/>
               </a:tblGrid>
               <a:tr h="365760">
                 <a:tc>
@@ -6072,6 +6072,7 @@
                     <a:bodyPr/>
                     <a:lstStyle/>
                     <a:p>
+                      <a:pPr algn="ctr"/>
                       <a:r>
                         <a:rPr sz="1200" b="1">
                           <a:solidFill>
@@ -6094,6 +6095,7 @@
                     <a:bodyPr/>
                     <a:lstStyle/>
                     <a:p>
+                      <a:pPr algn="l"/>
                       <a:r>
                         <a:rPr sz="1200" b="1">
                           <a:solidFill>
@@ -6116,6 +6118,7 @@
                     <a:bodyPr/>
                     <a:lstStyle/>
                     <a:p>
+                      <a:pPr algn="l"/>
                       <a:r>
                         <a:rPr sz="1200" b="1">
                           <a:solidFill>
@@ -6140,8 +6143,9 @@
                     <a:bodyPr/>
                     <a:lstStyle/>
                     <a:p>
+                      <a:pPr algn="ctr"/>
                       <a:r>
-                        <a:rPr sz="1100" b="0">
+                        <a:rPr sz="1800" b="1">
                           <a:solidFill>
                             <a:srgbClr val="465461"/>
                           </a:solidFill>
@@ -6153,7 +6157,7 @@
                   </a:txBody>
                   <a:tcPr marL="45000" marR="45000" marT="25000" marB="25000" anchor="ctr">
                     <a:solidFill>
-                      <a:srgbClr val="F1F2F6"/>
+                      <a:srgbClr val="FF7F7F"/>
                     </a:solidFill>
                   </a:tcPr>
                 </a:tc>
@@ -6175,7 +6179,7 @@
                   </a:txBody>
                   <a:tcPr marL="45000" marR="45000" marT="25000" marB="25000" anchor="ctr">
                     <a:solidFill>
-                      <a:srgbClr val="F1F2F6"/>
+                      <a:srgbClr val="FF7F7F"/>
                     </a:solidFill>
                   </a:tcPr>
                 </a:tc>
@@ -6197,7 +6201,7 @@
                   </a:txBody>
                   <a:tcPr marL="45000" marR="45000" marT="25000" marB="25000" anchor="ctr">
                     <a:solidFill>
-                      <a:srgbClr val="F1F2F6"/>
+                      <a:srgbClr val="FF7F7F"/>
                     </a:solidFill>
                   </a:tcPr>
                 </a:tc>
@@ -6208,8 +6212,9 @@
                     <a:bodyPr/>
                     <a:lstStyle/>
                     <a:p>
+                      <a:pPr algn="ctr"/>
                       <a:r>
-                        <a:rPr sz="1100" b="0">
+                        <a:rPr sz="1800" b="1">
                           <a:solidFill>
                             <a:srgbClr val="465461"/>
                           </a:solidFill>
@@ -6221,7 +6226,7 @@
                   </a:txBody>
                   <a:tcPr marL="45000" marR="45000" marT="25000" marB="25000" anchor="ctr">
                     <a:solidFill>
-                      <a:srgbClr val="FFFFFF"/>
+                      <a:srgbClr val="FFBF7F"/>
                     </a:solidFill>
                   </a:tcPr>
                 </a:tc>
@@ -6243,7 +6248,7 @@
                   </a:txBody>
                   <a:tcPr marL="45000" marR="45000" marT="25000" marB="25000" anchor="ctr">
                     <a:solidFill>
-                      <a:srgbClr val="FFFFFF"/>
+                      <a:srgbClr val="FFBF7F"/>
                     </a:solidFill>
                   </a:tcPr>
                 </a:tc>
@@ -6265,7 +6270,7 @@
                   </a:txBody>
                   <a:tcPr marL="45000" marR="45000" marT="25000" marB="25000" anchor="ctr">
                     <a:solidFill>
-                      <a:srgbClr val="FFFFFF"/>
+                      <a:srgbClr val="FFBF7F"/>
                     </a:solidFill>
                   </a:tcPr>
                 </a:tc>
@@ -6276,8 +6281,9 @@
                     <a:bodyPr/>
                     <a:lstStyle/>
                     <a:p>
+                      <a:pPr algn="ctr"/>
                       <a:r>
-                        <a:rPr sz="1100" b="0">
+                        <a:rPr sz="1800" b="1">
                           <a:solidFill>
                             <a:srgbClr val="465461"/>
                           </a:solidFill>
@@ -6289,7 +6295,7 @@
                   </a:txBody>
                   <a:tcPr marL="45000" marR="45000" marT="25000" marB="25000" anchor="ctr">
                     <a:solidFill>
-                      <a:srgbClr val="F1F2F6"/>
+                      <a:srgbClr val="FFDF7F"/>
                     </a:solidFill>
                   </a:tcPr>
                 </a:tc>
@@ -6311,7 +6317,7 @@
                   </a:txBody>
                   <a:tcPr marL="45000" marR="45000" marT="25000" marB="25000" anchor="ctr">
                     <a:solidFill>
-                      <a:srgbClr val="F1F2F6"/>
+                      <a:srgbClr val="FFDF7F"/>
                     </a:solidFill>
                   </a:tcPr>
                 </a:tc>
@@ -6333,7 +6339,7 @@
                   </a:txBody>
                   <a:tcPr marL="45000" marR="45000" marT="25000" marB="25000" anchor="ctr">
                     <a:solidFill>
-                      <a:srgbClr val="F1F2F6"/>
+                      <a:srgbClr val="FFDF7F"/>
                     </a:solidFill>
                   </a:tcPr>
                 </a:tc>
@@ -6344,8 +6350,9 @@
                     <a:bodyPr/>
                     <a:lstStyle/>
                     <a:p>
+                      <a:pPr algn="ctr"/>
                       <a:r>
-                        <a:rPr sz="1100" b="0">
+                        <a:rPr sz="1800" b="1">
                           <a:solidFill>
                             <a:srgbClr val="465461"/>
                           </a:solidFill>
@@ -6357,7 +6364,7 @@
                   </a:txBody>
                   <a:tcPr marL="45000" marR="45000" marT="25000" marB="25000" anchor="ctr">
                     <a:solidFill>
-                      <a:srgbClr val="FFFFFF"/>
+                      <a:srgbClr val="FFFF7F"/>
                     </a:solidFill>
                   </a:tcPr>
                 </a:tc>
@@ -6379,7 +6386,7 @@
                   </a:txBody>
                   <a:tcPr marL="45000" marR="45000" marT="25000" marB="25000" anchor="ctr">
                     <a:solidFill>
-                      <a:srgbClr val="FFFFFF"/>
+                      <a:srgbClr val="FFFF7F"/>
                     </a:solidFill>
                   </a:tcPr>
                 </a:tc>
@@ -6401,7 +6408,7 @@
                   </a:txBody>
                   <a:tcPr marL="45000" marR="45000" marT="25000" marB="25000" anchor="ctr">
                     <a:solidFill>
-                      <a:srgbClr val="FFFFFF"/>
+                      <a:srgbClr val="FFFF7F"/>
                     </a:solidFill>
                   </a:tcPr>
                 </a:tc>
@@ -6674,9 +6681,9 @@
                 <a:tableStyleId>{5C22544A-7EE6-4342-B048-85BDC9FD1C3A}</a:tableStyleId>
               </a:tblPr>
               <a:tblGrid>
-                <a:gridCol w="3352800"/>
-                <a:gridCol w="3352800"/>
-                <a:gridCol w="3352800"/>
+                <a:gridCol w="822960"/>
+                <a:gridCol w="4617720"/>
+                <a:gridCol w="4617720"/>
               </a:tblGrid>
               <a:tr h="365760">
                 <a:tc>
@@ -6684,6 +6691,7 @@
                     <a:bodyPr/>
                     <a:lstStyle/>
                     <a:p>
+                      <a:pPr algn="ctr"/>
                       <a:r>
                         <a:rPr sz="1200" b="1">
                           <a:solidFill>
@@ -6706,6 +6714,7 @@
                     <a:bodyPr/>
                     <a:lstStyle/>
                     <a:p>
+                      <a:pPr algn="l"/>
                       <a:r>
                         <a:rPr sz="1200" b="1">
                           <a:solidFill>
@@ -6728,6 +6737,7 @@
                     <a:bodyPr/>
                     <a:lstStyle/>
                     <a:p>
+                      <a:pPr algn="l"/>
                       <a:r>
                         <a:rPr sz="1200" b="1">
                           <a:solidFill>
@@ -6752,8 +6762,9 @@
                     <a:bodyPr/>
                     <a:lstStyle/>
                     <a:p>
+                      <a:pPr algn="ctr"/>
                       <a:r>
-                        <a:rPr sz="1100" b="0">
+                        <a:rPr sz="1800" b="1">
                           <a:solidFill>
                             <a:srgbClr val="465461"/>
                           </a:solidFill>
@@ -6765,7 +6776,7 @@
                   </a:txBody>
                   <a:tcPr marL="45000" marR="45000" marT="25000" marB="25000" anchor="ctr">
                     <a:solidFill>
-                      <a:srgbClr val="F1F2F6"/>
+                      <a:srgbClr val="FF7F7F"/>
                     </a:solidFill>
                   </a:tcPr>
                 </a:tc>
@@ -6787,7 +6798,7 @@
                   </a:txBody>
                   <a:tcPr marL="45000" marR="45000" marT="25000" marB="25000" anchor="ctr">
                     <a:solidFill>
-                      <a:srgbClr val="F1F2F6"/>
+                      <a:srgbClr val="FF7F7F"/>
                     </a:solidFill>
                   </a:tcPr>
                 </a:tc>
@@ -6809,7 +6820,7 @@
                   </a:txBody>
                   <a:tcPr marL="45000" marR="45000" marT="25000" marB="25000" anchor="ctr">
                     <a:solidFill>
-                      <a:srgbClr val="F1F2F6"/>
+                      <a:srgbClr val="FF7F7F"/>
                     </a:solidFill>
                   </a:tcPr>
                 </a:tc>
@@ -6820,8 +6831,9 @@
                     <a:bodyPr/>
                     <a:lstStyle/>
                     <a:p>
+                      <a:pPr algn="ctr"/>
                       <a:r>
-                        <a:rPr sz="1100" b="0">
+                        <a:rPr sz="1800" b="1">
                           <a:solidFill>
                             <a:srgbClr val="465461"/>
                           </a:solidFill>
@@ -6833,7 +6845,7 @@
                   </a:txBody>
                   <a:tcPr marL="45000" marR="45000" marT="25000" marB="25000" anchor="ctr">
                     <a:solidFill>
-                      <a:srgbClr val="FFFFFF"/>
+                      <a:srgbClr val="FFBF7F"/>
                     </a:solidFill>
                   </a:tcPr>
                 </a:tc>
@@ -6855,7 +6867,7 @@
                   </a:txBody>
                   <a:tcPr marL="45000" marR="45000" marT="25000" marB="25000" anchor="ctr">
                     <a:solidFill>
-                      <a:srgbClr val="FFFFFF"/>
+                      <a:srgbClr val="FFBF7F"/>
                     </a:solidFill>
                   </a:tcPr>
                 </a:tc>
@@ -6877,7 +6889,7 @@
                   </a:txBody>
                   <a:tcPr marL="45000" marR="45000" marT="25000" marB="25000" anchor="ctr">
                     <a:solidFill>
-                      <a:srgbClr val="FFFFFF"/>
+                      <a:srgbClr val="FFBF7F"/>
                     </a:solidFill>
                   </a:tcPr>
                 </a:tc>
@@ -6888,8 +6900,9 @@
                     <a:bodyPr/>
                     <a:lstStyle/>
                     <a:p>
+                      <a:pPr algn="ctr"/>
                       <a:r>
-                        <a:rPr sz="1100" b="0">
+                        <a:rPr sz="1800" b="1">
                           <a:solidFill>
                             <a:srgbClr val="465461"/>
                           </a:solidFill>
@@ -6901,7 +6914,7 @@
                   </a:txBody>
                   <a:tcPr marL="45000" marR="45000" marT="25000" marB="25000" anchor="ctr">
                     <a:solidFill>
-                      <a:srgbClr val="F1F2F6"/>
+                      <a:srgbClr val="FFDF7F"/>
                     </a:solidFill>
                   </a:tcPr>
                 </a:tc>
@@ -6923,7 +6936,7 @@
                   </a:txBody>
                   <a:tcPr marL="45000" marR="45000" marT="25000" marB="25000" anchor="ctr">
                     <a:solidFill>
-                      <a:srgbClr val="F1F2F6"/>
+                      <a:srgbClr val="FFDF7F"/>
                     </a:solidFill>
                   </a:tcPr>
                 </a:tc>
@@ -6945,7 +6958,7 @@
                   </a:txBody>
                   <a:tcPr marL="45000" marR="45000" marT="25000" marB="25000" anchor="ctr">
                     <a:solidFill>
-                      <a:srgbClr val="F1F2F6"/>
+                      <a:srgbClr val="FFDF7F"/>
                     </a:solidFill>
                   </a:tcPr>
                 </a:tc>
@@ -6956,8 +6969,9 @@
                     <a:bodyPr/>
                     <a:lstStyle/>
                     <a:p>
+                      <a:pPr algn="ctr"/>
                       <a:r>
-                        <a:rPr sz="1100" b="0">
+                        <a:rPr sz="1800" b="1">
                           <a:solidFill>
                             <a:srgbClr val="465461"/>
                           </a:solidFill>
@@ -6969,7 +6983,7 @@
                   </a:txBody>
                   <a:tcPr marL="45000" marR="45000" marT="25000" marB="25000" anchor="ctr">
                     <a:solidFill>
-                      <a:srgbClr val="FFFFFF"/>
+                      <a:srgbClr val="FFFF7F"/>
                     </a:solidFill>
                   </a:tcPr>
                 </a:tc>
@@ -6991,7 +7005,7 @@
                   </a:txBody>
                   <a:tcPr marL="45000" marR="45000" marT="25000" marB="25000" anchor="ctr">
                     <a:solidFill>
-                      <a:srgbClr val="FFFFFF"/>
+                      <a:srgbClr val="FFFF7F"/>
                     </a:solidFill>
                   </a:tcPr>
                 </a:tc>
@@ -7013,7 +7027,7 @@
                   </a:txBody>
                   <a:tcPr marL="45000" marR="45000" marT="25000" marB="25000" anchor="ctr">
                     <a:solidFill>
-                      <a:srgbClr val="FFFFFF"/>
+                      <a:srgbClr val="FFFF7F"/>
                     </a:solidFill>
                   </a:tcPr>
                 </a:tc>
@@ -7024,8 +7038,9 @@
                     <a:bodyPr/>
                     <a:lstStyle/>
                     <a:p>
+                      <a:pPr algn="ctr"/>
                       <a:r>
-                        <a:rPr sz="1100" b="0">
+                        <a:rPr sz="1800" b="1">
                           <a:solidFill>
                             <a:srgbClr val="465461"/>
                           </a:solidFill>
@@ -7037,7 +7052,7 @@
                   </a:txBody>
                   <a:tcPr marL="45000" marR="45000" marT="25000" marB="25000" anchor="ctr">
                     <a:solidFill>
-                      <a:srgbClr val="F1F2F6"/>
+                      <a:srgbClr val="BFFF7F"/>
                     </a:solidFill>
                   </a:tcPr>
                 </a:tc>
@@ -7059,7 +7074,7 @@
                   </a:txBody>
                   <a:tcPr marL="45000" marR="45000" marT="25000" marB="25000" anchor="ctr">
                     <a:solidFill>
-                      <a:srgbClr val="F1F2F6"/>
+                      <a:srgbClr val="BFFF7F"/>
                     </a:solidFill>
                   </a:tcPr>
                 </a:tc>
@@ -7081,7 +7096,7 @@
                   </a:txBody>
                   <a:tcPr marL="45000" marR="45000" marT="25000" marB="25000" anchor="ctr">
                     <a:solidFill>
-                      <a:srgbClr val="F1F2F6"/>
+                      <a:srgbClr val="BFFF7F"/>
                     </a:solidFill>
                   </a:tcPr>
                 </a:tc>

</xml_diff>